<commit_message>
Refresh submission claims for five-vendor parser
</commit_message>
<xml_diff>
--- a/submission/NetAudit_SIH26155_Technical_Presentation.pptx
+++ b/submission/NetAudit_SIH26155_Technical_Presentation.pptx
@@ -7350,7 +7350,7 @@
                 </a:solidFill>
                 <a:latin typeface="Aptos"/>
               </a:rPr>
-              <a:t>TODAY: Cisco + Fortinet · single-file UI · one 11-control CIS-inspired bundle · not CIS certification</a:t>
+              <a:t>TODAY: 5-vendor synthetic parsing corpus · single-file UI · 11-control bundle · not certification</a:t>
             </a:r>
           </a:p>
         </p:txBody>
@@ -7635,7 +7635,7 @@
             </a:r>
             <a:br/>
             <a:r>
-              <a:t>Juniper + Palo Alto</a:t>
+              <a:t>Real-device validation</a:t>
             </a:r>
           </a:p>
         </p:txBody>

</xml_diff>